<commit_message>
Give the Wesemann ladder its painkiller list and sixth slide
The presentation predated the six-slide structure and stopped at five,
because slide 3 is skipped when the JSON has no painkiller list. The ten
entries come from the "Umsetzung in Hivebuy (Pain Killer)" section of the
Granola note 513312796884 from 21.08.2026, with the shop count replaced
by punch-out catalogs per the skill's language rules.

The PDF is unchanged: painkiller only feeds slide 3, and a re-render
produced the same two pages, so the version from the meeting day stays
the record.

Co-Authored-By: Claude Opus 5 <noreply@anthropic.com>
Claude-Session: https://claude.ai/code/session_012oWyUSWf5ZiJJNpmrjt8g8
</commit_message>
<xml_diff>
--- a/.claude/skills/impact-ladder-pdf/output/2026-08-21-impact-ladder-wesemann.pptx
+++ b/.claude/skills/impact-ladder-pdf/output/2026-08-21-impact-ladder-wesemann.pptx
@@ -10,6 +10,7 @@
     <p:sldId id="258" r:id="rId9"/>
     <p:sldId id="259" r:id="rId10"/>
     <p:sldId id="260" r:id="rId11"/>
+    <p:sldId id="261" r:id="rId12"/>
   </p:sldIdLst>
   <p:sldSz cx="12192120" cy="6858000" type="screen4x3"/>
   <p:notesSz cx="6858000" cy="9144000"/>
@@ -1828,7 +1829,7 @@
                 </a:solidFill>
                 <a:latin typeface="DM Sans"/>
               </a:rPr>
-              <a:t>IMPACT LADDER, EBENE 1 UND 2</a:t>
+              <a:t>WIE OPTIMIERT HIVEBUY DEN PROZESS</a:t>
             </a:r>
           </a:p>
         </p:txBody>
@@ -1927,69 +1928,14 @@
       </p:sp>
       <p:sp>
         <p:nvSpPr>
-          <p:cNvPr id="6" name="Rounded Rectangle 5"/>
-          <p:cNvSpPr/>
-          <p:nvPr/>
-        </p:nvSpPr>
-        <p:spPr>
-          <a:xfrm>
-            <a:off x="936000" y="1224000"/>
-            <a:ext cx="396000" cy="396000"/>
-          </a:xfrm>
-          <a:prstGeom prst="roundRect">
-            <a:avLst>
-              <a:gd name="adj" fmla="val 6000"/>
-            </a:avLst>
-          </a:prstGeom>
-          <a:solidFill>
-            <a:srgbClr val="204540"/>
-          </a:solidFill>
-          <a:ln>
-            <a:noFill/>
-          </a:ln>
-          <a:effectLst/>
-        </p:spPr>
-        <p:style>
-          <a:lnRef idx="1">
-            <a:schemeClr val="accent1"/>
-          </a:lnRef>
-          <a:fillRef idx="3">
-            <a:schemeClr val="accent1"/>
-          </a:fillRef>
-          <a:effectRef idx="2">
-            <a:schemeClr val="accent1"/>
-          </a:effectRef>
-          <a:fontRef idx="minor">
-            <a:schemeClr val="lt1"/>
-          </a:fontRef>
-        </p:style>
-        <p:txBody>
-          <a:bodyPr rtlCol="0" anchor="ctr" wrap="square"/>
-          <a:lstStyle/>
-          <a:p>
-            <a:pPr algn="ctr"/>
-            <a:r>
-              <a:rPr sz="1400" b="1">
-                <a:solidFill>
-                  <a:srgbClr val="F1FF45"/>
-                </a:solidFill>
-                <a:latin typeface="DM Sans"/>
-              </a:rPr>
-              <a:t>1</a:t>
-            </a:r>
-          </a:p>
-        </p:txBody>
-      </p:sp>
-      <p:sp>
-        <p:nvSpPr>
-          <p:cNvPr id="7" name="TextBox 6"/>
+          <p:cNvPr id="6" name="TextBox 5"/>
           <p:cNvSpPr txBox="1"/>
           <p:nvPr/>
         </p:nvSpPr>
         <p:spPr>
           <a:xfrm>
-            <a:off x="1440000" y="1260000"/>
-            <a:ext cx="4260060" cy="576000"/>
+            <a:off x="1008000" y="1296000"/>
+            <a:ext cx="4620060" cy="4662000"/>
           </a:xfrm>
           <a:prstGeom prst="rect">
             <a:avLst/>
@@ -2004,48 +1950,25 @@
           <a:p>
             <a:pPr>
               <a:lnSpc>
-                <a:spcPct val="110000"/>
-              </a:lnSpc>
-              <a:spcBef>
-                <a:spcPts val="0"/>
-              </a:spcBef>
-              <a:spcAft>
-                <a:spcPts val="0"/>
-              </a:spcAft>
-            </a:pPr>
-            <a:r>
-              <a:rPr sz="1700" b="0">
+                <a:spcPct val="130000"/>
+              </a:lnSpc>
+              <a:spcBef>
+                <a:spcPts val="0"/>
+              </a:spcBef>
+              <a:spcAft>
+                <a:spcPts val="900"/>
+              </a:spcAft>
+            </a:pPr>
+            <a:r>
+              <a:rPr sz="1300" b="0">
                 <a:solidFill>
                   <a:srgbClr val="204540"/>
                 </a:solidFill>
-                <a:latin typeface="Frank Ruhl Libre"/>
-              </a:rPr>
-              <a:t>Mitarbeitende / Bedarfsträger</a:t>
-            </a:r>
-          </a:p>
-        </p:txBody>
-      </p:sp>
-      <p:sp>
-        <p:nvSpPr>
-          <p:cNvPr id="8" name="TextBox 7"/>
-          <p:cNvSpPr txBox="1"/>
-          <p:nvPr/>
-        </p:nvSpPr>
-        <p:spPr>
-          <a:xfrm>
-            <a:off x="936000" y="1980000"/>
-            <a:ext cx="4764060" cy="3438000"/>
-          </a:xfrm>
-          <a:prstGeom prst="rect">
-            <a:avLst/>
-          </a:prstGeom>
-          <a:noFill/>
-        </p:spPr>
-        <p:txBody>
-          <a:bodyPr wrap="square" lIns="0" rIns="0" tIns="0" bIns="0">
-            <a:spAutoFit/>
-          </a:bodyPr>
-          <a:lstStyle/>
+                <a:latin typeface="DM Sans"/>
+              </a:rPr>
+              <a:t>•  Anforderung über eine Oberfläche für Katalog, Punch-out und Freitext (Intake Agent)</a:t>
+            </a:r>
+          </a:p>
           <a:p>
             <a:pPr>
               <a:lnSpc>
@@ -2055,7 +1978,7 @@
                 <a:spcPts val="0"/>
               </a:spcBef>
               <a:spcAft>
-                <a:spcPts val="700"/>
+                <a:spcPts val="900"/>
               </a:spcAft>
             </a:pPr>
             <a:r>
@@ -2065,7 +1988,7 @@
                 </a:solidFill>
                 <a:latin typeface="DM Sans"/>
               </a:rPr>
-              <a:t>•  Stücklisten und Angebote werden hochgeladen, alle Positionen sind in 20 Sekunden ausgelesen (Parsing Agent).</a:t>
+              <a:t>•  Angebote und Stücklisten hochladen, die Positionen werden in Sekunden ausgelesen (Parsing Agent)</a:t>
             </a:r>
           </a:p>
           <a:p>
@@ -2077,7 +2000,7 @@
                 <a:spcPts val="0"/>
               </a:spcBef>
               <a:spcAft>
-                <a:spcPts val="700"/>
+                <a:spcPts val="900"/>
               </a:spcAft>
             </a:pPr>
             <a:r>
@@ -2087,114 +2010,58 @@
                 </a:solidFill>
                 <a:latin typeface="DM Sans"/>
               </a:rPr>
-              <a:t>•  Suche über Kataloge und angebundene Onlineshops an einer Stelle (Intake Agent, Status Agent).</a:t>
-            </a:r>
-          </a:p>
-        </p:txBody>
-      </p:sp>
-      <p:sp>
-        <p:nvSpPr>
-          <p:cNvPr id="9" name="Rounded Rectangle 8"/>
-          <p:cNvSpPr/>
-          <p:nvPr/>
-        </p:nvSpPr>
-        <p:spPr>
-          <a:xfrm>
-            <a:off x="936000" y="5490000"/>
-            <a:ext cx="792000" cy="252000"/>
-          </a:xfrm>
-          <a:prstGeom prst="roundRect">
-            <a:avLst>
-              <a:gd name="adj" fmla="val 6000"/>
-            </a:avLst>
-          </a:prstGeom>
-          <a:solidFill>
-            <a:srgbClr val="F1FF45"/>
-          </a:solidFill>
-          <a:ln>
-            <a:noFill/>
-          </a:ln>
-          <a:effectLst/>
-        </p:spPr>
-        <p:style>
-          <a:lnRef idx="1">
-            <a:schemeClr val="accent1"/>
-          </a:lnRef>
-          <a:fillRef idx="3">
-            <a:schemeClr val="accent1"/>
-          </a:fillRef>
-          <a:effectRef idx="2">
-            <a:schemeClr val="accent1"/>
-          </a:effectRef>
-          <a:fontRef idx="minor">
-            <a:schemeClr val="lt1"/>
-          </a:fontRef>
-        </p:style>
-        <p:txBody>
-          <a:bodyPr rtlCol="0" anchor="ctr" wrap="square"/>
-          <a:lstStyle/>
-          <a:p>
-            <a:pPr algn="ctr"/>
-            <a:r>
-              <a:rPr sz="900" b="1">
+              <a:t>•  Integrierte Punch-out-Kataloge für den Bedarf, der heute über Onlineshops läuft</a:t>
+            </a:r>
+          </a:p>
+          <a:p>
+            <a:pPr>
+              <a:lnSpc>
+                <a:spcPct val="130000"/>
+              </a:lnSpc>
+              <a:spcBef>
+                <a:spcPts val="0"/>
+              </a:spcBef>
+              <a:spcAft>
+                <a:spcPts val="900"/>
+              </a:spcAft>
+            </a:pPr>
+            <a:r>
+              <a:rPr sz="1300" b="0">
                 <a:solidFill>
                   <a:srgbClr val="204540"/>
                 </a:solidFill>
                 <a:latin typeface="DM Sans"/>
               </a:rPr>
-              <a:t>IMPACT</a:t>
-            </a:r>
-          </a:p>
-        </p:txBody>
-      </p:sp>
-      <p:sp>
-        <p:nvSpPr>
-          <p:cNvPr id="10" name="TextBox 9"/>
-          <p:cNvSpPr txBox="1"/>
-          <p:nvPr/>
-        </p:nvSpPr>
-        <p:spPr>
-          <a:xfrm>
-            <a:off x="1836000" y="5472000"/>
-            <a:ext cx="3828060" cy="576000"/>
-          </a:xfrm>
-          <a:prstGeom prst="rect">
-            <a:avLst/>
-          </a:prstGeom>
-          <a:noFill/>
-        </p:spPr>
-        <p:txBody>
-          <a:bodyPr wrap="square" lIns="0" rIns="0" tIns="0" bIns="0">
-            <a:spAutoFit/>
-          </a:bodyPr>
-          <a:lstStyle/>
-          <a:p>
-            <a:pPr>
-              <a:lnSpc>
-                <a:spcPct val="125000"/>
-              </a:lnSpc>
-              <a:spcBef>
-                <a:spcPts val="0"/>
-              </a:spcBef>
-              <a:spcAft>
-                <a:spcPts val="0"/>
-              </a:spcAft>
-            </a:pPr>
-            <a:r>
-              <a:rPr sz="1200" b="1">
-                <a:solidFill>
-                  <a:srgbClr val="3E5B56"/>
-                </a:solidFill>
-                <a:latin typeface="DM Sans"/>
-              </a:rPr>
-              <a:t>Das Heraussuchen und Eintippen von Positionen entfällt.</a:t>
-            </a:r>
-          </a:p>
-        </p:txBody>
-      </p:sp>
-      <p:sp>
-        <p:nvSpPr>
-          <p:cNvPr id="11" name="Rounded Rectangle 10"/>
+              <a:t>•  Digitale Freigaben nach Wert, Warengruppe und Kostenstelle (Approval Agent)</a:t>
+            </a:r>
+          </a:p>
+          <a:p>
+            <a:pPr>
+              <a:lnSpc>
+                <a:spcPct val="130000"/>
+              </a:lnSpc>
+              <a:spcBef>
+                <a:spcPts val="0"/>
+              </a:spcBef>
+              <a:spcAft>
+                <a:spcPts val="900"/>
+              </a:spcAft>
+            </a:pPr>
+            <a:r>
+              <a:rPr sz="1300" b="0">
+                <a:solidFill>
+                  <a:srgbClr val="204540"/>
+                </a:solidFill>
+                <a:latin typeface="DM Sans"/>
+              </a:rPr>
+              <a:t>•  Automatische Vorkontierung und Weiterleitung im Freigabeweg (Accounting Agent)</a:t>
+            </a:r>
+          </a:p>
+        </p:txBody>
+      </p:sp>
+      <p:sp>
+        <p:nvSpPr>
+          <p:cNvPr id="7" name="Rounded Rectangle 6"/>
           <p:cNvSpPr/>
           <p:nvPr/>
         </p:nvSpPr>
@@ -2242,7 +2109,7 @@
       </p:sp>
       <p:sp>
         <p:nvSpPr>
-          <p:cNvPr id="12" name="Rectangle 11"/>
+          <p:cNvPr id="8" name="Rectangle 7"/>
           <p:cNvSpPr/>
           <p:nvPr/>
         </p:nvSpPr>
@@ -2286,69 +2153,14 @@
       </p:sp>
       <p:sp>
         <p:nvSpPr>
-          <p:cNvPr id="13" name="Rounded Rectangle 12"/>
-          <p:cNvSpPr/>
-          <p:nvPr/>
-        </p:nvSpPr>
-        <p:spPr>
-          <a:xfrm>
-            <a:off x="6492060" y="1224000"/>
-            <a:ext cx="396000" cy="396000"/>
-          </a:xfrm>
-          <a:prstGeom prst="roundRect">
-            <a:avLst>
-              <a:gd name="adj" fmla="val 6000"/>
-            </a:avLst>
-          </a:prstGeom>
-          <a:solidFill>
-            <a:srgbClr val="204540"/>
-          </a:solidFill>
-          <a:ln>
-            <a:noFill/>
-          </a:ln>
-          <a:effectLst/>
-        </p:spPr>
-        <p:style>
-          <a:lnRef idx="1">
-            <a:schemeClr val="accent1"/>
-          </a:lnRef>
-          <a:fillRef idx="3">
-            <a:schemeClr val="accent1"/>
-          </a:fillRef>
-          <a:effectRef idx="2">
-            <a:schemeClr val="accent1"/>
-          </a:effectRef>
-          <a:fontRef idx="minor">
-            <a:schemeClr val="lt1"/>
-          </a:fontRef>
-        </p:style>
-        <p:txBody>
-          <a:bodyPr rtlCol="0" anchor="ctr" wrap="square"/>
-          <a:lstStyle/>
-          <a:p>
-            <a:pPr algn="ctr"/>
-            <a:r>
-              <a:rPr sz="1400" b="1">
-                <a:solidFill>
-                  <a:srgbClr val="F1FF45"/>
-                </a:solidFill>
-                <a:latin typeface="DM Sans"/>
-              </a:rPr>
-              <a:t>2</a:t>
-            </a:r>
-          </a:p>
-        </p:txBody>
-      </p:sp>
-      <p:sp>
-        <p:nvSpPr>
-          <p:cNvPr id="14" name="TextBox 13"/>
+          <p:cNvPr id="9" name="TextBox 8"/>
           <p:cNvSpPr txBox="1"/>
           <p:nvPr/>
         </p:nvSpPr>
         <p:spPr>
           <a:xfrm>
-            <a:off x="6996060" y="1260000"/>
-            <a:ext cx="4260060" cy="576000"/>
+            <a:off x="6564060" y="1296000"/>
+            <a:ext cx="4620060" cy="4662000"/>
           </a:xfrm>
           <a:prstGeom prst="rect">
             <a:avLst/>
@@ -2363,48 +2175,25 @@
           <a:p>
             <a:pPr>
               <a:lnSpc>
-                <a:spcPct val="110000"/>
-              </a:lnSpc>
-              <a:spcBef>
-                <a:spcPts val="0"/>
-              </a:spcBef>
-              <a:spcAft>
-                <a:spcPts val="0"/>
-              </a:spcAft>
-            </a:pPr>
-            <a:r>
-              <a:rPr sz="1700" b="0">
+                <a:spcPct val="130000"/>
+              </a:lnSpc>
+              <a:spcBef>
+                <a:spcPts val="0"/>
+              </a:spcBef>
+              <a:spcAft>
+                <a:spcPts val="900"/>
+              </a:spcAft>
+            </a:pPr>
+            <a:r>
+              <a:rPr sz="1300" b="0">
                 <a:solidFill>
                   <a:srgbClr val="204540"/>
                 </a:solidFill>
-                <a:latin typeface="Frank Ruhl Libre"/>
-              </a:rPr>
-              <a:t>Einkauf / Administration</a:t>
-            </a:r>
-          </a:p>
-        </p:txBody>
-      </p:sp>
-      <p:sp>
-        <p:nvSpPr>
-          <p:cNvPr id="15" name="TextBox 14"/>
-          <p:cNvSpPr txBox="1"/>
-          <p:nvPr/>
-        </p:nvSpPr>
-        <p:spPr>
-          <a:xfrm>
-            <a:off x="6492060" y="1980000"/>
-            <a:ext cx="4764060" cy="3438000"/>
-          </a:xfrm>
-          <a:prstGeom prst="rect">
-            <a:avLst/>
-          </a:prstGeom>
-          <a:noFill/>
-        </p:spPr>
-        <p:txBody>
-          <a:bodyPr wrap="square" lIns="0" rIns="0" tIns="0" bIns="0">
-            <a:spAutoFit/>
-          </a:bodyPr>
-          <a:lstStyle/>
+                <a:latin typeface="DM Sans"/>
+              </a:rPr>
+              <a:t>•  Automatische Bestellung nach der letzten Freigabe, ohne manuellen Klick</a:t>
+            </a:r>
+          </a:p>
           <a:p>
             <a:pPr>
               <a:lnSpc>
@@ -2414,7 +2203,7 @@
                 <a:spcPts val="0"/>
               </a:spcBef>
               <a:spcAft>
-                <a:spcPts val="700"/>
+                <a:spcPts val="900"/>
               </a:spcAft>
             </a:pPr>
             <a:r>
@@ -2424,7 +2213,7 @@
                 </a:solidFill>
                 <a:latin typeface="DM Sans"/>
               </a:rPr>
-              <a:t>•  Freigaben laufen regelbasiert nach Wert, Warengruppe und Kostenstelle, die Bestellung löst danach automatisch aus (Approval Agent).</a:t>
+              <a:t>•  Automatische Übergabe der Bestellung an das ERP</a:t>
             </a:r>
           </a:p>
           <a:p>
@@ -2436,7 +2225,7 @@
                 <a:spcPts val="0"/>
               </a:spcBef>
               <a:spcAft>
-                <a:spcPts val="700"/>
+                <a:spcPts val="900"/>
               </a:spcAft>
             </a:pPr>
             <a:r>
@@ -2446,107 +2235,51 @@
                 </a:solidFill>
                 <a:latin typeface="DM Sans"/>
               </a:rPr>
-              <a:t>•  Ein nachvollziehbarer Standardprozess für Freitext, Katalog und Onlineshop (Intake Agent).</a:t>
-            </a:r>
-          </a:p>
-        </p:txBody>
-      </p:sp>
-      <p:sp>
-        <p:nvSpPr>
-          <p:cNvPr id="16" name="Rounded Rectangle 15"/>
-          <p:cNvSpPr/>
-          <p:nvPr/>
-        </p:nvSpPr>
-        <p:spPr>
-          <a:xfrm>
-            <a:off x="6492060" y="5490000"/>
-            <a:ext cx="792000" cy="252000"/>
-          </a:xfrm>
-          <a:prstGeom prst="roundRect">
-            <a:avLst>
-              <a:gd name="adj" fmla="val 6000"/>
-            </a:avLst>
-          </a:prstGeom>
-          <a:solidFill>
-            <a:srgbClr val="F1FF45"/>
-          </a:solidFill>
-          <a:ln>
-            <a:noFill/>
-          </a:ln>
-          <a:effectLst/>
-        </p:spPr>
-        <p:style>
-          <a:lnRef idx="1">
-            <a:schemeClr val="accent1"/>
-          </a:lnRef>
-          <a:fillRef idx="3">
-            <a:schemeClr val="accent1"/>
-          </a:fillRef>
-          <a:effectRef idx="2">
-            <a:schemeClr val="accent1"/>
-          </a:effectRef>
-          <a:fontRef idx="minor">
-            <a:schemeClr val="lt1"/>
-          </a:fontRef>
-        </p:style>
-        <p:txBody>
-          <a:bodyPr rtlCol="0" anchor="ctr" wrap="square"/>
-          <a:lstStyle/>
-          <a:p>
-            <a:pPr algn="ctr"/>
-            <a:r>
-              <a:rPr sz="900" b="1">
+              <a:t>•  Auftragsbestätigungen und Liefertermine werden der Bestellung zugeordnet (Status Agent)</a:t>
+            </a:r>
+          </a:p>
+          <a:p>
+            <a:pPr>
+              <a:lnSpc>
+                <a:spcPct val="130000"/>
+              </a:lnSpc>
+              <a:spcBef>
+                <a:spcPts val="0"/>
+              </a:spcBef>
+              <a:spcAft>
+                <a:spcPts val="900"/>
+              </a:spcAft>
+            </a:pPr>
+            <a:r>
+              <a:rPr sz="1300" b="0">
                 <a:solidFill>
                   <a:srgbClr val="204540"/>
                 </a:solidFill>
                 <a:latin typeface="DM Sans"/>
               </a:rPr>
-              <a:t>IMPACT</a:t>
-            </a:r>
-          </a:p>
-        </p:txBody>
-      </p:sp>
-      <p:sp>
-        <p:nvSpPr>
-          <p:cNvPr id="17" name="TextBox 16"/>
-          <p:cNvSpPr txBox="1"/>
-          <p:nvPr/>
-        </p:nvSpPr>
-        <p:spPr>
-          <a:xfrm>
-            <a:off x="7392060" y="5472000"/>
-            <a:ext cx="3828060" cy="576000"/>
-          </a:xfrm>
-          <a:prstGeom prst="rect">
-            <a:avLst/>
-          </a:prstGeom>
-          <a:noFill/>
-        </p:spPr>
-        <p:txBody>
-          <a:bodyPr wrap="square" lIns="0" rIns="0" tIns="0" bIns="0">
-            <a:spAutoFit/>
-          </a:bodyPr>
-          <a:lstStyle/>
-          <a:p>
-            <a:pPr>
-              <a:lnSpc>
-                <a:spcPct val="125000"/>
-              </a:lnSpc>
-              <a:spcBef>
-                <a:spcPts val="0"/>
-              </a:spcBef>
-              <a:spcAft>
-                <a:spcPts val="0"/>
-              </a:spcAft>
-            </a:pPr>
-            <a:r>
-              <a:rPr sz="1200" b="1">
-                <a:solidFill>
-                  <a:srgbClr val="3E5B56"/>
-                </a:solidFill>
-                <a:latin typeface="DM Sans"/>
-              </a:rPr>
-              <a:t>Die sechs Personen im Einkauf gewinnen den Großteil der 167 Stunden pro Monat zurück.</a:t>
+              <a:t>•  Automatischer Abgleich von Rechnung, Bestellung und Wareneingang (Invoice Agent)</a:t>
+            </a:r>
+          </a:p>
+          <a:p>
+            <a:pPr>
+              <a:lnSpc>
+                <a:spcPct val="130000"/>
+              </a:lnSpc>
+              <a:spcBef>
+                <a:spcPts val="0"/>
+              </a:spcBef>
+              <a:spcAft>
+                <a:spcPts val="900"/>
+              </a:spcAft>
+            </a:pPr>
+            <a:r>
+              <a:rPr sz="1300" b="0">
+                <a:solidFill>
+                  <a:srgbClr val="204540"/>
+                </a:solidFill>
+                <a:latin typeface="DM Sans"/>
+              </a:rPr>
+              <a:t>•  Auswertung nach Warengruppe, Lieferant und Abteilung (Analytics Agent)</a:t>
             </a:r>
           </a:p>
         </p:txBody>
@@ -2653,7 +2386,7 @@
                 </a:solidFill>
                 <a:latin typeface="DM Sans"/>
               </a:rPr>
-              <a:t>IMPACT LADDER, EBENE 3 UND 4</a:t>
+              <a:t>VORTEILE FÜR BEDARFSTRÄGER UND DEN EINKAUF</a:t>
             </a:r>
           </a:p>
         </p:txBody>
@@ -2800,7 +2533,7 @@
                 </a:solidFill>
                 <a:latin typeface="DM Sans"/>
               </a:rPr>
-              <a:t>3</a:t>
+              <a:t>1</a:t>
             </a:r>
           </a:p>
         </p:txBody>
@@ -2845,7 +2578,7 @@
                 </a:solidFill>
                 <a:latin typeface="Frank Ruhl Libre"/>
               </a:rPr>
-              <a:t>Finance / Controlling</a:t>
+              <a:t>Mitarbeitende / Bedarfsträger</a:t>
             </a:r>
           </a:p>
         </p:txBody>
@@ -2890,7 +2623,7 @@
                 </a:solidFill>
                 <a:latin typeface="DM Sans"/>
               </a:rPr>
-              <a:t>•  Warengruppe, Kostenstelle und Sachkonto werden bei der Auswahl vorbelegt (Category Agent, Accounting Agent).</a:t>
+              <a:t>•  Stücklisten und Angebote werden hochgeladen, alle Positionen sind in 20 Sekunden ausgelesen (Parsing Agent).</a:t>
             </a:r>
           </a:p>
           <a:p>
@@ -2912,7 +2645,7 @@
                 </a:solidFill>
                 <a:latin typeface="DM Sans"/>
               </a:rPr>
-              <a:t>•  Rechnungen werden automatisch mit der Bestellung abgeglichen, die Buchhaltung greift nur bei Abweichungen ein (Invoice Agent).</a:t>
+              <a:t>•  Suche über Kataloge und angebundene Onlineshops an einer Stelle (Intake Agent, Status Agent).</a:t>
             </a:r>
           </a:p>
         </p:txBody>
@@ -3012,7 +2745,7 @@
                 </a:solidFill>
                 <a:latin typeface="DM Sans"/>
               </a:rPr>
-              <a:t>Die manuelle Rechnungsprüfung wird zur Ausnahme statt zur Regel.</a:t>
+              <a:t>Das Heraussuchen und Eintippen von Positionen entfällt.</a:t>
             </a:r>
           </a:p>
         </p:txBody>
@@ -3159,7 +2892,7 @@
                 </a:solidFill>
                 <a:latin typeface="DM Sans"/>
               </a:rPr>
-              <a:t>4</a:t>
+              <a:t>2</a:t>
             </a:r>
           </a:p>
         </p:txBody>
@@ -3204,7 +2937,7 @@
                 </a:solidFill>
                 <a:latin typeface="Frank Ruhl Libre"/>
               </a:rPr>
-              <a:t>Geschäftsführung / Management</a:t>
+              <a:t>Einkauf / Administration</a:t>
             </a:r>
           </a:p>
         </p:txBody>
@@ -3249,7 +2982,7 @@
                 </a:solidFill>
                 <a:latin typeface="DM Sans"/>
               </a:rPr>
-              <a:t>•  Auswertbare Zahlen über Bestellvolumen, Lieferanten und Bearbeitungszeiten (Analytics Agent).</a:t>
+              <a:t>•  Freigaben laufen regelbasiert nach Wert, Warengruppe und Kostenstelle, die Bestellung löst danach automatisch aus (Approval Agent).</a:t>
             </a:r>
           </a:p>
           <a:p>
@@ -3271,7 +3004,7 @@
                 </a:solidFill>
                 <a:latin typeface="DM Sans"/>
               </a:rPr>
-              <a:t>•  Dokumentierte Freigabewege und nur freigegebene Lieferanten, unabhängig von einzelnen Personen (Compliance Agent).</a:t>
+              <a:t>•  Ein nachvollziehbarer Standardprozess für Freitext, Katalog und Onlineshop (Intake Agent).</a:t>
             </a:r>
           </a:p>
         </p:txBody>
@@ -3371,7 +3104,7 @@
                 </a:solidFill>
                 <a:latin typeface="DM Sans"/>
               </a:rPr>
-              <a:t>Der Einkaufsprozess funktioniert auch ohne besetzte Einkaufsleitung.</a:t>
+              <a:t>Die sechs Personen im Einkauf gewinnen den Großteil der 167 Stunden pro Monat zurück.</a:t>
             </a:r>
           </a:p>
         </p:txBody>
@@ -3478,7 +3211,832 @@
                 </a:solidFill>
                 <a:latin typeface="DM Sans"/>
               </a:rPr>
-              <a:t>EXECUTIVE SUMMARY</a:t>
+              <a:t>VORTEILE FÜR FINANCE &amp; CONTROLLING UND DIE GESCHÄFTSFÜHRUNG</a:t>
+            </a:r>
+          </a:p>
+        </p:txBody>
+      </p:sp>
+      <p:sp>
+        <p:nvSpPr>
+          <p:cNvPr id="4" name="Rounded Rectangle 3"/>
+          <p:cNvSpPr/>
+          <p:nvPr/>
+        </p:nvSpPr>
+        <p:spPr>
+          <a:xfrm>
+            <a:off x="684000" y="972000"/>
+            <a:ext cx="5268060" cy="5310000"/>
+          </a:xfrm>
+          <a:prstGeom prst="roundRect">
+            <a:avLst>
+              <a:gd name="adj" fmla="val 6000"/>
+            </a:avLst>
+          </a:prstGeom>
+          <a:solidFill>
+            <a:srgbClr val="FFFFFF"/>
+          </a:solidFill>
+          <a:ln w="12700">
+            <a:solidFill>
+              <a:srgbClr val="E3E9E7"/>
+            </a:solidFill>
+          </a:ln>
+          <a:effectLst/>
+        </p:spPr>
+        <p:style>
+          <a:lnRef idx="1">
+            <a:schemeClr val="accent1"/>
+          </a:lnRef>
+          <a:fillRef idx="3">
+            <a:schemeClr val="accent1"/>
+          </a:fillRef>
+          <a:effectRef idx="2">
+            <a:schemeClr val="accent1"/>
+          </a:effectRef>
+          <a:fontRef idx="minor">
+            <a:schemeClr val="lt1"/>
+          </a:fontRef>
+        </p:style>
+        <p:txBody>
+          <a:bodyPr rtlCol="0" anchor="ctr" wrap="square"/>
+          <a:lstStyle/>
+          <a:p>
+            <a:pPr algn="ctr"/>
+          </a:p>
+        </p:txBody>
+      </p:sp>
+      <p:sp>
+        <p:nvSpPr>
+          <p:cNvPr id="5" name="Rectangle 4"/>
+          <p:cNvSpPr/>
+          <p:nvPr/>
+        </p:nvSpPr>
+        <p:spPr>
+          <a:xfrm>
+            <a:off x="684000" y="972000"/>
+            <a:ext cx="57600" cy="5310000"/>
+          </a:xfrm>
+          <a:prstGeom prst="rect">
+            <a:avLst/>
+          </a:prstGeom>
+          <a:solidFill>
+            <a:srgbClr val="228C7D"/>
+          </a:solidFill>
+          <a:ln>
+            <a:noFill/>
+          </a:ln>
+          <a:effectLst/>
+        </p:spPr>
+        <p:style>
+          <a:lnRef idx="1">
+            <a:schemeClr val="accent1"/>
+          </a:lnRef>
+          <a:fillRef idx="3">
+            <a:schemeClr val="accent1"/>
+          </a:fillRef>
+          <a:effectRef idx="2">
+            <a:schemeClr val="accent1"/>
+          </a:effectRef>
+          <a:fontRef idx="minor">
+            <a:schemeClr val="lt1"/>
+          </a:fontRef>
+        </p:style>
+        <p:txBody>
+          <a:bodyPr rtlCol="0" anchor="ctr"/>
+          <a:lstStyle/>
+          <a:p>
+            <a:pPr algn="ctr"/>
+          </a:p>
+        </p:txBody>
+      </p:sp>
+      <p:sp>
+        <p:nvSpPr>
+          <p:cNvPr id="6" name="Rounded Rectangle 5"/>
+          <p:cNvSpPr/>
+          <p:nvPr/>
+        </p:nvSpPr>
+        <p:spPr>
+          <a:xfrm>
+            <a:off x="936000" y="1224000"/>
+            <a:ext cx="396000" cy="396000"/>
+          </a:xfrm>
+          <a:prstGeom prst="roundRect">
+            <a:avLst>
+              <a:gd name="adj" fmla="val 6000"/>
+            </a:avLst>
+          </a:prstGeom>
+          <a:solidFill>
+            <a:srgbClr val="204540"/>
+          </a:solidFill>
+          <a:ln>
+            <a:noFill/>
+          </a:ln>
+          <a:effectLst/>
+        </p:spPr>
+        <p:style>
+          <a:lnRef idx="1">
+            <a:schemeClr val="accent1"/>
+          </a:lnRef>
+          <a:fillRef idx="3">
+            <a:schemeClr val="accent1"/>
+          </a:fillRef>
+          <a:effectRef idx="2">
+            <a:schemeClr val="accent1"/>
+          </a:effectRef>
+          <a:fontRef idx="minor">
+            <a:schemeClr val="lt1"/>
+          </a:fontRef>
+        </p:style>
+        <p:txBody>
+          <a:bodyPr rtlCol="0" anchor="ctr" wrap="square"/>
+          <a:lstStyle/>
+          <a:p>
+            <a:pPr algn="ctr"/>
+            <a:r>
+              <a:rPr sz="1400" b="1">
+                <a:solidFill>
+                  <a:srgbClr val="F1FF45"/>
+                </a:solidFill>
+                <a:latin typeface="DM Sans"/>
+              </a:rPr>
+              <a:t>3</a:t>
+            </a:r>
+          </a:p>
+        </p:txBody>
+      </p:sp>
+      <p:sp>
+        <p:nvSpPr>
+          <p:cNvPr id="7" name="TextBox 6"/>
+          <p:cNvSpPr txBox="1"/>
+          <p:nvPr/>
+        </p:nvSpPr>
+        <p:spPr>
+          <a:xfrm>
+            <a:off x="1440000" y="1260000"/>
+            <a:ext cx="4260060" cy="576000"/>
+          </a:xfrm>
+          <a:prstGeom prst="rect">
+            <a:avLst/>
+          </a:prstGeom>
+          <a:noFill/>
+        </p:spPr>
+        <p:txBody>
+          <a:bodyPr wrap="square" lIns="0" rIns="0" tIns="0" bIns="0">
+            <a:spAutoFit/>
+          </a:bodyPr>
+          <a:lstStyle/>
+          <a:p>
+            <a:pPr>
+              <a:lnSpc>
+                <a:spcPct val="110000"/>
+              </a:lnSpc>
+              <a:spcBef>
+                <a:spcPts val="0"/>
+              </a:spcBef>
+              <a:spcAft>
+                <a:spcPts val="0"/>
+              </a:spcAft>
+            </a:pPr>
+            <a:r>
+              <a:rPr sz="1700" b="0">
+                <a:solidFill>
+                  <a:srgbClr val="204540"/>
+                </a:solidFill>
+                <a:latin typeface="Frank Ruhl Libre"/>
+              </a:rPr>
+              <a:t>Finance / Controlling</a:t>
+            </a:r>
+          </a:p>
+        </p:txBody>
+      </p:sp>
+      <p:sp>
+        <p:nvSpPr>
+          <p:cNvPr id="8" name="TextBox 7"/>
+          <p:cNvSpPr txBox="1"/>
+          <p:nvPr/>
+        </p:nvSpPr>
+        <p:spPr>
+          <a:xfrm>
+            <a:off x="936000" y="1980000"/>
+            <a:ext cx="4764060" cy="3438000"/>
+          </a:xfrm>
+          <a:prstGeom prst="rect">
+            <a:avLst/>
+          </a:prstGeom>
+          <a:noFill/>
+        </p:spPr>
+        <p:txBody>
+          <a:bodyPr wrap="square" lIns="0" rIns="0" tIns="0" bIns="0">
+            <a:spAutoFit/>
+          </a:bodyPr>
+          <a:lstStyle/>
+          <a:p>
+            <a:pPr>
+              <a:lnSpc>
+                <a:spcPct val="130000"/>
+              </a:lnSpc>
+              <a:spcBef>
+                <a:spcPts val="0"/>
+              </a:spcBef>
+              <a:spcAft>
+                <a:spcPts val="700"/>
+              </a:spcAft>
+            </a:pPr>
+            <a:r>
+              <a:rPr sz="1300" b="0">
+                <a:solidFill>
+                  <a:srgbClr val="204540"/>
+                </a:solidFill>
+                <a:latin typeface="DM Sans"/>
+              </a:rPr>
+              <a:t>•  Warengruppe, Kostenstelle und Sachkonto werden bei der Auswahl vorbelegt (Category Agent, Accounting Agent).</a:t>
+            </a:r>
+          </a:p>
+          <a:p>
+            <a:pPr>
+              <a:lnSpc>
+                <a:spcPct val="130000"/>
+              </a:lnSpc>
+              <a:spcBef>
+                <a:spcPts val="0"/>
+              </a:spcBef>
+              <a:spcAft>
+                <a:spcPts val="700"/>
+              </a:spcAft>
+            </a:pPr>
+            <a:r>
+              <a:rPr sz="1300" b="0">
+                <a:solidFill>
+                  <a:srgbClr val="204540"/>
+                </a:solidFill>
+                <a:latin typeface="DM Sans"/>
+              </a:rPr>
+              <a:t>•  Rechnungen werden automatisch mit der Bestellung abgeglichen, die Buchhaltung greift nur bei Abweichungen ein (Invoice Agent).</a:t>
+            </a:r>
+          </a:p>
+        </p:txBody>
+      </p:sp>
+      <p:sp>
+        <p:nvSpPr>
+          <p:cNvPr id="9" name="Rounded Rectangle 8"/>
+          <p:cNvSpPr/>
+          <p:nvPr/>
+        </p:nvSpPr>
+        <p:spPr>
+          <a:xfrm>
+            <a:off x="936000" y="5490000"/>
+            <a:ext cx="792000" cy="252000"/>
+          </a:xfrm>
+          <a:prstGeom prst="roundRect">
+            <a:avLst>
+              <a:gd name="adj" fmla="val 6000"/>
+            </a:avLst>
+          </a:prstGeom>
+          <a:solidFill>
+            <a:srgbClr val="F1FF45"/>
+          </a:solidFill>
+          <a:ln>
+            <a:noFill/>
+          </a:ln>
+          <a:effectLst/>
+        </p:spPr>
+        <p:style>
+          <a:lnRef idx="1">
+            <a:schemeClr val="accent1"/>
+          </a:lnRef>
+          <a:fillRef idx="3">
+            <a:schemeClr val="accent1"/>
+          </a:fillRef>
+          <a:effectRef idx="2">
+            <a:schemeClr val="accent1"/>
+          </a:effectRef>
+          <a:fontRef idx="minor">
+            <a:schemeClr val="lt1"/>
+          </a:fontRef>
+        </p:style>
+        <p:txBody>
+          <a:bodyPr rtlCol="0" anchor="ctr" wrap="square"/>
+          <a:lstStyle/>
+          <a:p>
+            <a:pPr algn="ctr"/>
+            <a:r>
+              <a:rPr sz="900" b="1">
+                <a:solidFill>
+                  <a:srgbClr val="204540"/>
+                </a:solidFill>
+                <a:latin typeface="DM Sans"/>
+              </a:rPr>
+              <a:t>IMPACT</a:t>
+            </a:r>
+          </a:p>
+        </p:txBody>
+      </p:sp>
+      <p:sp>
+        <p:nvSpPr>
+          <p:cNvPr id="10" name="TextBox 9"/>
+          <p:cNvSpPr txBox="1"/>
+          <p:nvPr/>
+        </p:nvSpPr>
+        <p:spPr>
+          <a:xfrm>
+            <a:off x="1836000" y="5472000"/>
+            <a:ext cx="3828060" cy="576000"/>
+          </a:xfrm>
+          <a:prstGeom prst="rect">
+            <a:avLst/>
+          </a:prstGeom>
+          <a:noFill/>
+        </p:spPr>
+        <p:txBody>
+          <a:bodyPr wrap="square" lIns="0" rIns="0" tIns="0" bIns="0">
+            <a:spAutoFit/>
+          </a:bodyPr>
+          <a:lstStyle/>
+          <a:p>
+            <a:pPr>
+              <a:lnSpc>
+                <a:spcPct val="125000"/>
+              </a:lnSpc>
+              <a:spcBef>
+                <a:spcPts val="0"/>
+              </a:spcBef>
+              <a:spcAft>
+                <a:spcPts val="0"/>
+              </a:spcAft>
+            </a:pPr>
+            <a:r>
+              <a:rPr sz="1200" b="1">
+                <a:solidFill>
+                  <a:srgbClr val="3E5B56"/>
+                </a:solidFill>
+                <a:latin typeface="DM Sans"/>
+              </a:rPr>
+              <a:t>Die manuelle Rechnungsprüfung wird zur Ausnahme statt zur Regel.</a:t>
+            </a:r>
+          </a:p>
+        </p:txBody>
+      </p:sp>
+      <p:sp>
+        <p:nvSpPr>
+          <p:cNvPr id="11" name="Rounded Rectangle 10"/>
+          <p:cNvSpPr/>
+          <p:nvPr/>
+        </p:nvSpPr>
+        <p:spPr>
+          <a:xfrm>
+            <a:off x="6240060" y="972000"/>
+            <a:ext cx="5268060" cy="5310000"/>
+          </a:xfrm>
+          <a:prstGeom prst="roundRect">
+            <a:avLst>
+              <a:gd name="adj" fmla="val 6000"/>
+            </a:avLst>
+          </a:prstGeom>
+          <a:solidFill>
+            <a:srgbClr val="FFFFFF"/>
+          </a:solidFill>
+          <a:ln w="12700">
+            <a:solidFill>
+              <a:srgbClr val="E3E9E7"/>
+            </a:solidFill>
+          </a:ln>
+          <a:effectLst/>
+        </p:spPr>
+        <p:style>
+          <a:lnRef idx="1">
+            <a:schemeClr val="accent1"/>
+          </a:lnRef>
+          <a:fillRef idx="3">
+            <a:schemeClr val="accent1"/>
+          </a:fillRef>
+          <a:effectRef idx="2">
+            <a:schemeClr val="accent1"/>
+          </a:effectRef>
+          <a:fontRef idx="minor">
+            <a:schemeClr val="lt1"/>
+          </a:fontRef>
+        </p:style>
+        <p:txBody>
+          <a:bodyPr rtlCol="0" anchor="ctr" wrap="square"/>
+          <a:lstStyle/>
+          <a:p>
+            <a:pPr algn="ctr"/>
+          </a:p>
+        </p:txBody>
+      </p:sp>
+      <p:sp>
+        <p:nvSpPr>
+          <p:cNvPr id="12" name="Rectangle 11"/>
+          <p:cNvSpPr/>
+          <p:nvPr/>
+        </p:nvSpPr>
+        <p:spPr>
+          <a:xfrm>
+            <a:off x="6240060" y="972000"/>
+            <a:ext cx="57600" cy="5310000"/>
+          </a:xfrm>
+          <a:prstGeom prst="rect">
+            <a:avLst/>
+          </a:prstGeom>
+          <a:solidFill>
+            <a:srgbClr val="228C7D"/>
+          </a:solidFill>
+          <a:ln>
+            <a:noFill/>
+          </a:ln>
+          <a:effectLst/>
+        </p:spPr>
+        <p:style>
+          <a:lnRef idx="1">
+            <a:schemeClr val="accent1"/>
+          </a:lnRef>
+          <a:fillRef idx="3">
+            <a:schemeClr val="accent1"/>
+          </a:fillRef>
+          <a:effectRef idx="2">
+            <a:schemeClr val="accent1"/>
+          </a:effectRef>
+          <a:fontRef idx="minor">
+            <a:schemeClr val="lt1"/>
+          </a:fontRef>
+        </p:style>
+        <p:txBody>
+          <a:bodyPr rtlCol="0" anchor="ctr"/>
+          <a:lstStyle/>
+          <a:p>
+            <a:pPr algn="ctr"/>
+          </a:p>
+        </p:txBody>
+      </p:sp>
+      <p:sp>
+        <p:nvSpPr>
+          <p:cNvPr id="13" name="Rounded Rectangle 12"/>
+          <p:cNvSpPr/>
+          <p:nvPr/>
+        </p:nvSpPr>
+        <p:spPr>
+          <a:xfrm>
+            <a:off x="6492060" y="1224000"/>
+            <a:ext cx="396000" cy="396000"/>
+          </a:xfrm>
+          <a:prstGeom prst="roundRect">
+            <a:avLst>
+              <a:gd name="adj" fmla="val 6000"/>
+            </a:avLst>
+          </a:prstGeom>
+          <a:solidFill>
+            <a:srgbClr val="204540"/>
+          </a:solidFill>
+          <a:ln>
+            <a:noFill/>
+          </a:ln>
+          <a:effectLst/>
+        </p:spPr>
+        <p:style>
+          <a:lnRef idx="1">
+            <a:schemeClr val="accent1"/>
+          </a:lnRef>
+          <a:fillRef idx="3">
+            <a:schemeClr val="accent1"/>
+          </a:fillRef>
+          <a:effectRef idx="2">
+            <a:schemeClr val="accent1"/>
+          </a:effectRef>
+          <a:fontRef idx="minor">
+            <a:schemeClr val="lt1"/>
+          </a:fontRef>
+        </p:style>
+        <p:txBody>
+          <a:bodyPr rtlCol="0" anchor="ctr" wrap="square"/>
+          <a:lstStyle/>
+          <a:p>
+            <a:pPr algn="ctr"/>
+            <a:r>
+              <a:rPr sz="1400" b="1">
+                <a:solidFill>
+                  <a:srgbClr val="F1FF45"/>
+                </a:solidFill>
+                <a:latin typeface="DM Sans"/>
+              </a:rPr>
+              <a:t>4</a:t>
+            </a:r>
+          </a:p>
+        </p:txBody>
+      </p:sp>
+      <p:sp>
+        <p:nvSpPr>
+          <p:cNvPr id="14" name="TextBox 13"/>
+          <p:cNvSpPr txBox="1"/>
+          <p:nvPr/>
+        </p:nvSpPr>
+        <p:spPr>
+          <a:xfrm>
+            <a:off x="6996060" y="1260000"/>
+            <a:ext cx="4260060" cy="576000"/>
+          </a:xfrm>
+          <a:prstGeom prst="rect">
+            <a:avLst/>
+          </a:prstGeom>
+          <a:noFill/>
+        </p:spPr>
+        <p:txBody>
+          <a:bodyPr wrap="square" lIns="0" rIns="0" tIns="0" bIns="0">
+            <a:spAutoFit/>
+          </a:bodyPr>
+          <a:lstStyle/>
+          <a:p>
+            <a:pPr>
+              <a:lnSpc>
+                <a:spcPct val="110000"/>
+              </a:lnSpc>
+              <a:spcBef>
+                <a:spcPts val="0"/>
+              </a:spcBef>
+              <a:spcAft>
+                <a:spcPts val="0"/>
+              </a:spcAft>
+            </a:pPr>
+            <a:r>
+              <a:rPr sz="1700" b="0">
+                <a:solidFill>
+                  <a:srgbClr val="204540"/>
+                </a:solidFill>
+                <a:latin typeface="Frank Ruhl Libre"/>
+              </a:rPr>
+              <a:t>Geschäftsführung / Management</a:t>
+            </a:r>
+          </a:p>
+        </p:txBody>
+      </p:sp>
+      <p:sp>
+        <p:nvSpPr>
+          <p:cNvPr id="15" name="TextBox 14"/>
+          <p:cNvSpPr txBox="1"/>
+          <p:nvPr/>
+        </p:nvSpPr>
+        <p:spPr>
+          <a:xfrm>
+            <a:off x="6492060" y="1980000"/>
+            <a:ext cx="4764060" cy="3438000"/>
+          </a:xfrm>
+          <a:prstGeom prst="rect">
+            <a:avLst/>
+          </a:prstGeom>
+          <a:noFill/>
+        </p:spPr>
+        <p:txBody>
+          <a:bodyPr wrap="square" lIns="0" rIns="0" tIns="0" bIns="0">
+            <a:spAutoFit/>
+          </a:bodyPr>
+          <a:lstStyle/>
+          <a:p>
+            <a:pPr>
+              <a:lnSpc>
+                <a:spcPct val="130000"/>
+              </a:lnSpc>
+              <a:spcBef>
+                <a:spcPts val="0"/>
+              </a:spcBef>
+              <a:spcAft>
+                <a:spcPts val="700"/>
+              </a:spcAft>
+            </a:pPr>
+            <a:r>
+              <a:rPr sz="1300" b="0">
+                <a:solidFill>
+                  <a:srgbClr val="204540"/>
+                </a:solidFill>
+                <a:latin typeface="DM Sans"/>
+              </a:rPr>
+              <a:t>•  Auswertbare Zahlen über Bestellvolumen, Lieferanten und Bearbeitungszeiten (Analytics Agent).</a:t>
+            </a:r>
+          </a:p>
+          <a:p>
+            <a:pPr>
+              <a:lnSpc>
+                <a:spcPct val="130000"/>
+              </a:lnSpc>
+              <a:spcBef>
+                <a:spcPts val="0"/>
+              </a:spcBef>
+              <a:spcAft>
+                <a:spcPts val="700"/>
+              </a:spcAft>
+            </a:pPr>
+            <a:r>
+              <a:rPr sz="1300" b="0">
+                <a:solidFill>
+                  <a:srgbClr val="204540"/>
+                </a:solidFill>
+                <a:latin typeface="DM Sans"/>
+              </a:rPr>
+              <a:t>•  Dokumentierte Freigabewege und nur freigegebene Lieferanten, unabhängig von einzelnen Personen (Compliance Agent).</a:t>
+            </a:r>
+          </a:p>
+        </p:txBody>
+      </p:sp>
+      <p:sp>
+        <p:nvSpPr>
+          <p:cNvPr id="16" name="Rounded Rectangle 15"/>
+          <p:cNvSpPr/>
+          <p:nvPr/>
+        </p:nvSpPr>
+        <p:spPr>
+          <a:xfrm>
+            <a:off x="6492060" y="5490000"/>
+            <a:ext cx="792000" cy="252000"/>
+          </a:xfrm>
+          <a:prstGeom prst="roundRect">
+            <a:avLst>
+              <a:gd name="adj" fmla="val 6000"/>
+            </a:avLst>
+          </a:prstGeom>
+          <a:solidFill>
+            <a:srgbClr val="F1FF45"/>
+          </a:solidFill>
+          <a:ln>
+            <a:noFill/>
+          </a:ln>
+          <a:effectLst/>
+        </p:spPr>
+        <p:style>
+          <a:lnRef idx="1">
+            <a:schemeClr val="accent1"/>
+          </a:lnRef>
+          <a:fillRef idx="3">
+            <a:schemeClr val="accent1"/>
+          </a:fillRef>
+          <a:effectRef idx="2">
+            <a:schemeClr val="accent1"/>
+          </a:effectRef>
+          <a:fontRef idx="minor">
+            <a:schemeClr val="lt1"/>
+          </a:fontRef>
+        </p:style>
+        <p:txBody>
+          <a:bodyPr rtlCol="0" anchor="ctr" wrap="square"/>
+          <a:lstStyle/>
+          <a:p>
+            <a:pPr algn="ctr"/>
+            <a:r>
+              <a:rPr sz="900" b="1">
+                <a:solidFill>
+                  <a:srgbClr val="204540"/>
+                </a:solidFill>
+                <a:latin typeface="DM Sans"/>
+              </a:rPr>
+              <a:t>IMPACT</a:t>
+            </a:r>
+          </a:p>
+        </p:txBody>
+      </p:sp>
+      <p:sp>
+        <p:nvSpPr>
+          <p:cNvPr id="17" name="TextBox 16"/>
+          <p:cNvSpPr txBox="1"/>
+          <p:nvPr/>
+        </p:nvSpPr>
+        <p:spPr>
+          <a:xfrm>
+            <a:off x="7392060" y="5472000"/>
+            <a:ext cx="3828060" cy="576000"/>
+          </a:xfrm>
+          <a:prstGeom prst="rect">
+            <a:avLst/>
+          </a:prstGeom>
+          <a:noFill/>
+        </p:spPr>
+        <p:txBody>
+          <a:bodyPr wrap="square" lIns="0" rIns="0" tIns="0" bIns="0">
+            <a:spAutoFit/>
+          </a:bodyPr>
+          <a:lstStyle/>
+          <a:p>
+            <a:pPr>
+              <a:lnSpc>
+                <a:spcPct val="125000"/>
+              </a:lnSpc>
+              <a:spcBef>
+                <a:spcPts val="0"/>
+              </a:spcBef>
+              <a:spcAft>
+                <a:spcPts val="0"/>
+              </a:spcAft>
+            </a:pPr>
+            <a:r>
+              <a:rPr sz="1200" b="1">
+                <a:solidFill>
+                  <a:srgbClr val="3E5B56"/>
+                </a:solidFill>
+                <a:latin typeface="DM Sans"/>
+              </a:rPr>
+              <a:t>Der Einkaufsprozess funktioniert auch ohne besetzte Einkaufsleitung.</a:t>
+            </a:r>
+          </a:p>
+        </p:txBody>
+      </p:sp>
+    </p:spTree>
+  </p:cSld>
+  <p:clrMapOvr>
+    <a:masterClrMapping/>
+  </p:clrMapOvr>
+</p:sld>
+</file>
+
+<file path=ppt/slides/slide6.xml><?xml version="1.0" encoding="utf-8"?>
+<p:sld xmlns:a="http://schemas.openxmlformats.org/drawingml/2006/main" xmlns:p="http://schemas.openxmlformats.org/presentationml/2006/main" xmlns:r="http://schemas.openxmlformats.org/officeDocument/2006/relationships">
+  <p:cSld>
+    <p:spTree>
+      <p:nvGrpSpPr>
+        <p:cNvPr id="1" name=""/>
+        <p:cNvGrpSpPr/>
+        <p:nvPr/>
+      </p:nvGrpSpPr>
+      <p:grpSpPr/>
+      <p:sp>
+        <p:nvSpPr>
+          <p:cNvPr id="2" name="Rectangle 1"/>
+          <p:cNvSpPr/>
+          <p:nvPr/>
+        </p:nvSpPr>
+        <p:spPr>
+          <a:xfrm>
+            <a:off x="0" y="0"/>
+            <a:ext cx="12192120" cy="6858000"/>
+          </a:xfrm>
+          <a:prstGeom prst="rect">
+            <a:avLst/>
+          </a:prstGeom>
+          <a:solidFill>
+            <a:srgbClr val="FBFBFB"/>
+          </a:solidFill>
+          <a:ln>
+            <a:noFill/>
+          </a:ln>
+          <a:effectLst/>
+        </p:spPr>
+        <p:style>
+          <a:lnRef idx="1">
+            <a:schemeClr val="accent1"/>
+          </a:lnRef>
+          <a:fillRef idx="3">
+            <a:schemeClr val="accent1"/>
+          </a:fillRef>
+          <a:effectRef idx="2">
+            <a:schemeClr val="accent1"/>
+          </a:effectRef>
+          <a:fontRef idx="minor">
+            <a:schemeClr val="lt1"/>
+          </a:fontRef>
+        </p:style>
+        <p:txBody>
+          <a:bodyPr rtlCol="0" anchor="ctr"/>
+          <a:lstStyle/>
+          <a:p>
+            <a:pPr algn="ctr"/>
+          </a:p>
+        </p:txBody>
+      </p:sp>
+      <p:sp>
+        <p:nvSpPr>
+          <p:cNvPr id="3" name="TextBox 2"/>
+          <p:cNvSpPr txBox="1"/>
+          <p:nvPr/>
+        </p:nvSpPr>
+        <p:spPr>
+          <a:xfrm>
+            <a:off x="684000" y="576000"/>
+            <a:ext cx="10824120" cy="288000"/>
+          </a:xfrm>
+          <a:prstGeom prst="rect">
+            <a:avLst/>
+          </a:prstGeom>
+          <a:noFill/>
+        </p:spPr>
+        <p:txBody>
+          <a:bodyPr wrap="square" lIns="0" rIns="0" tIns="0" bIns="0">
+            <a:spAutoFit/>
+          </a:bodyPr>
+          <a:lstStyle/>
+          <a:p>
+            <a:pPr>
+              <a:lnSpc>
+                <a:spcPct val="125000"/>
+              </a:lnSpc>
+              <a:spcBef>
+                <a:spcPts val="0"/>
+              </a:spcBef>
+              <a:spcAft>
+                <a:spcPts val="0"/>
+              </a:spcAft>
+            </a:pPr>
+            <a:r>
+              <a:rPr sz="1200" b="1">
+                <a:solidFill>
+                  <a:srgbClr val="228C7D"/>
+                </a:solidFill>
+                <a:latin typeface="DM Sans"/>
+              </a:rPr>
+              <a:t>ZUSAMMENFASSUNG</a:t>
             </a:r>
           </a:p>
         </p:txBody>

</xml_diff>